<commit_message>
docs: add the paper figures and drop the Skylo credit from the slides
Co-authored-by: Cursor <cursoragent@cursor.com>
</commit_message>
<xml_diff>
--- a/docs/NTN_ISAC_in_GNU_Radio.pptx
+++ b/docs/NTN_ISAC_in_GNU_Radio.pptx
@@ -1721,7 +1721,7 @@
           <a:p>
             <a:r>
               <a:rPr lang="en-US" dirty="0"/>
-              <a:t>Most of the research literature highlights the challenges in NTN ISAC: the rapid motion of LEO satellites, the unmodified OFDM waveform and its limits, the need for tight clock synchronization across the bistatic nodes, and a lack of channel models for joint NTN communication and sensing, among others. I work in the 5G NTN space as a Systems Engineer at Skylo, and I am a fan of signals of opportunity: using existing signals meant for one thing to do something else entirely. So I wanted to explore how ISAC can work over LEO satellites from the point of view of an end user, a receiver on the ground. I wanted to build on current research and test the limits on actual hardware, so I took a few of these open questions and started building. First, a standalone simulator with standard 5G NR waveforms and a new channel block for a LEO system, where you can add moving and stationary objects and clutter and see how the echoes arrive at the receiver. Second, accuracy. Most of the literature uses pilot signals, which are broadcast periodically but are not dense. For sensing, a denser reference should do better. The receiver has already demodulated the data for communication, so why not use it for sensing too? That is payload-assisted sensing. Third, how this holds up on an actual hardware platform, across different synchronization levels and different RF chains, since that is a highlighted open research item. Wording tips so every claim is exact: say demodulated rather than decoded (the chain uses hard QPSK decisions, with no LDPC decoding). Payload-aided references are known from DVB-T and DAB passive radar (Poullin, 2005) and recent 5G NR passive radar; what is new here is doing it for NTN and comparing pilots, payload and genie from one dwell. The hardware tests so far are conducted over cable.</a:t>
+              <a:t>Most of the research literature highlights the challenges in NTN ISAC: the rapid motion of LEO satellites, the unmodified OFDM waveform and its limits, the need for tight clock synchronization across the bistatic nodes, and a lack of channel models for joint NTN communication and sensing, among others. I work in the 5G NTN space, and I am a fan of signals of opportunity: using existing signals meant for one thing to do something else entirely. So I wanted to explore how ISAC can work over LEO satellites from the point of view of an end user, a receiver on the ground. I wanted to build on current research and test the limits on actual hardware, so I took a few of these open questions and started building. First, a standalone simulator with standard 5G NR waveforms and a new channel block for a LEO system, where you can add moving and stationary objects and clutter and see how the echoes arrive at the receiver. Second, accuracy. Most of the literature uses pilot signals, which are broadcast periodically but are not dense. For sensing, a denser reference should do better. The receiver has already demodulated the data for communication, so why not use it for sensing too? That is payload-assisted sensing. Third, how this holds up on an actual hardware platform, across different synchronization levels and different RF chains, since that is a highlighted open research item. Wording tips so every claim is exact: say demodulated rather than decoded (the chain uses hard QPSK decisions, with no LDPC decoding). Payload-aided references are known from DVB-T and DAB passive radar (Poullin, 2005) and recent 5G NR passive radar; what is new here is doing it for NTN and comparing pilots, payload and genie from one dwell. The hardware tests so far are conducted over cable.</a:t>
             </a:r>
           </a:p>
         </p:txBody>
@@ -2898,40 +2898,7 @@
                 <a:ea typeface="IBM Plex Sans" pitchFamily="34" charset="-122"/>
                 <a:cs typeface="IBM Plex Sans" pitchFamily="34" charset="-120"/>
               </a:rPr>
-              <a:t>Soham Desai</a:t>
-            </a:r>
-            <a:r>
-              <a:rPr lang="en-US" sz="1400" dirty="0">
-                <a:solidFill>
-                  <a:srgbClr val="F3F1EC"/>
-                </a:solidFill>
-                <a:latin typeface="IBM Plex Sans" pitchFamily="34" charset="0"/>
-                <a:ea typeface="IBM Plex Sans" pitchFamily="34" charset="-122"/>
-                <a:cs typeface="IBM Plex Sans" pitchFamily="34" charset="-120"/>
-              </a:rPr>
-              <a:t> · </a:t>
-            </a:r>
-            <a:r>
-              <a:rPr lang="en-US" sz="1400" dirty="0" err="1">
-                <a:solidFill>
-                  <a:srgbClr val="F3F1EC"/>
-                </a:solidFill>
-                <a:latin typeface="IBM Plex Sans" pitchFamily="34" charset="0"/>
-                <a:ea typeface="IBM Plex Sans" pitchFamily="34" charset="-122"/>
-                <a:cs typeface="IBM Plex Sans" pitchFamily="34" charset="-120"/>
-              </a:rPr>
-              <a:t>Skylo</a:t>
-            </a:r>
-            <a:r>
-              <a:rPr lang="en-US" sz="1400" dirty="0">
-                <a:solidFill>
-                  <a:srgbClr val="F3F1EC"/>
-                </a:solidFill>
-                <a:latin typeface="IBM Plex Sans" pitchFamily="34" charset="0"/>
-                <a:ea typeface="IBM Plex Sans" pitchFamily="34" charset="-122"/>
-                <a:cs typeface="IBM Plex Sans" pitchFamily="34" charset="-120"/>
-              </a:rPr>
-              <a:t> Tech</a:t>
+              <a:t>Soham</a:t>
             </a:r>
             <a:endParaRPr lang="en-US" sz="1400" dirty="0"/>
           </a:p>
@@ -17164,7 +17131,7 @@
                 <a:ea typeface="IBM Plex Sans" pitchFamily="34" charset="-122"/>
                 <a:cs typeface="IBM Plex Sans" pitchFamily="34" charset="-120"/>
               </a:rPr>
-              <a:t>Soham Desai</a:t>
+              <a:t>Soham</a:t>
             </a:r>
           </a:p>
           <a:p>
@@ -17324,25 +17291,6 @@
             <a:normAutofit/>
           </a:bodyPr>
           <a:lstStyle/>
-          <a:p>
-            <a:pPr marL="0" indent="0" algn="l">
-              <a:lnSpc>
-                <a:spcPts val="1960"/>
-              </a:lnSpc>
-              <a:buNone/>
-            </a:pPr>
-            <a:r>
-              <a:rPr lang="en-US" sz="1400" b="1" dirty="0">
-                <a:solidFill>
-                  <a:srgbClr val="F3F1EC"/>
-                </a:solidFill>
-                <a:latin typeface="IBM Plex Sans" pitchFamily="34" charset="0"/>
-                <a:ea typeface="IBM Plex Sans" pitchFamily="34" charset="-122"/>
-                <a:cs typeface="IBM Plex Sans" pitchFamily="34" charset="-120"/>
-              </a:rPr>
-              <a:t>soham@skylo.tech</a:t>
-            </a:r>
-          </a:p>
           <a:p>
             <a:pPr marL="0" indent="0" algn="l">
               <a:lnSpc>

</xml_diff>